<commit_message>
Update BOM.xlsx, PartsLocation.pptx indicates F1 as jumper.
</commit_message>
<xml_diff>
--- a/hardware/PartsLocation.pptx
+++ b/hardware/PartsLocation.pptx
@@ -135,22 +135,6 @@
       </a:defRPr>
     </a:lvl9pPr>
   </p:defaultTextStyle>
-  <p:extLst>
-    <p:ext uri="{EFAFB233-063F-42B5-8137-9DF3F51BA10A}">
-      <p15:sldGuideLst xmlns:p15="http://schemas.microsoft.com/office/powerpoint/2012/main">
-        <p15:guide id="1" orient="horz" pos="2160">
-          <p15:clr>
-            <a:srgbClr val="A4A3A4"/>
-          </p15:clr>
-        </p15:guide>
-        <p15:guide id="2" pos="2880">
-          <p15:clr>
-            <a:srgbClr val="A4A3A4"/>
-          </p15:clr>
-        </p15:guide>
-      </p15:sldGuideLst>
-    </p:ext>
-  </p:extLst>
 </p:presentation>
 </file>
 
@@ -342,12 +326,12 @@
             <a:pPr>
               <a:defRPr/>
             </a:pPr>
-            <a:fld id="{F9A0D457-1631-445C-9167-502622A945D8}" type="slidenum">
+            <a:fld id="{13B62E1E-7B02-432C-9596-4CE9C5B79D63}" type="slidenum">
               <a:rPr lang="en-US" altLang="ja-JP"/>
               <a:pPr>
                 <a:defRPr/>
               </a:pPr>
-              <a:t>‹#›</a:t>
+              <a:t>&lt;#&gt;</a:t>
             </a:fld>
             <a:endParaRPr lang="en-US" altLang="ja-JP"/>
           </a:p>
@@ -563,12 +547,12 @@
             <a:pPr>
               <a:defRPr/>
             </a:pPr>
-            <a:fld id="{39F64DE9-F7BF-4D84-A452-E99D3587E497}" type="slidenum">
+            <a:fld id="{8A6B097C-706F-43B2-90A2-6E3664764701}" type="slidenum">
               <a:rPr lang="en-US" altLang="ja-JP"/>
               <a:pPr>
                 <a:defRPr/>
               </a:pPr>
-              <a:t>‹#›</a:t>
+              <a:t>&lt;#&gt;</a:t>
             </a:fld>
             <a:endParaRPr lang="en-US" altLang="ja-JP"/>
           </a:p>
@@ -794,12 +778,12 @@
             <a:pPr>
               <a:defRPr/>
             </a:pPr>
-            <a:fld id="{838D7BFE-6652-44F6-B998-C9BE195221A1}" type="slidenum">
+            <a:fld id="{F0D03366-23D8-4A2C-8CD0-229569972944}" type="slidenum">
               <a:rPr lang="en-US" altLang="ja-JP"/>
               <a:pPr>
                 <a:defRPr/>
               </a:pPr>
-              <a:t>‹#›</a:t>
+              <a:t>&lt;#&gt;</a:t>
             </a:fld>
             <a:endParaRPr lang="en-US" altLang="ja-JP"/>
           </a:p>
@@ -1015,12 +999,12 @@
             <a:pPr>
               <a:defRPr/>
             </a:pPr>
-            <a:fld id="{39994D0F-5B07-471B-94A8-D7C418B12BAD}" type="slidenum">
+            <a:fld id="{399CA5C7-2662-432F-BBA7-D37464DBD84C}" type="slidenum">
               <a:rPr lang="en-US" altLang="ja-JP"/>
               <a:pPr>
                 <a:defRPr/>
               </a:pPr>
-              <a:t>‹#›</a:t>
+              <a:t>&lt;#&gt;</a:t>
             </a:fld>
             <a:endParaRPr lang="en-US" altLang="ja-JP"/>
           </a:p>
@@ -1227,12 +1211,12 @@
             <a:pPr>
               <a:defRPr/>
             </a:pPr>
-            <a:fld id="{030F5199-E418-4860-8AC7-4DAB24E13683}" type="slidenum">
+            <a:fld id="{046C88A0-508B-4943-ABE4-C70E625D72DD}" type="slidenum">
               <a:rPr lang="en-US" altLang="ja-JP"/>
               <a:pPr>
                 <a:defRPr/>
               </a:pPr>
-              <a:t>‹#›</a:t>
+              <a:t>&lt;#&gt;</a:t>
             </a:fld>
             <a:endParaRPr lang="en-US" altLang="ja-JP"/>
           </a:p>
@@ -1597,12 +1581,12 @@
             <a:pPr>
               <a:defRPr/>
             </a:pPr>
-            <a:fld id="{8CE5F7E7-A4D9-4E37-B686-CCB200858E7D}" type="slidenum">
+            <a:fld id="{88A062DE-2A12-4D9B-8B1E-E053A60BEC73}" type="slidenum">
               <a:rPr lang="en-US" altLang="ja-JP"/>
               <a:pPr>
                 <a:defRPr/>
               </a:pPr>
-              <a:t>‹#›</a:t>
+              <a:t>&lt;#&gt;</a:t>
             </a:fld>
             <a:endParaRPr lang="en-US" altLang="ja-JP"/>
           </a:p>
@@ -2101,12 +2085,12 @@
             <a:pPr>
               <a:defRPr/>
             </a:pPr>
-            <a:fld id="{05F0D26C-5EB4-4ECC-BCA8-0FF419EE6672}" type="slidenum">
+            <a:fld id="{2802C64F-46E3-4605-9F32-8E4E60F6BC46}" type="slidenum">
               <a:rPr lang="en-US" altLang="ja-JP"/>
               <a:pPr>
                 <a:defRPr/>
               </a:pPr>
-              <a:t>‹#›</a:t>
+              <a:t>&lt;#&gt;</a:t>
             </a:fld>
             <a:endParaRPr lang="en-US" altLang="ja-JP"/>
           </a:p>
@@ -2239,12 +2223,12 @@
             <a:pPr>
               <a:defRPr/>
             </a:pPr>
-            <a:fld id="{25E886BB-2CF9-4B7C-BFD3-1123A538F052}" type="slidenum">
+            <a:fld id="{41BE4783-D11E-4D04-93DD-F52CBF77CAC7}" type="slidenum">
               <a:rPr lang="en-US" altLang="ja-JP"/>
               <a:pPr>
                 <a:defRPr/>
               </a:pPr>
-              <a:t>‹#›</a:t>
+              <a:t>&lt;#&gt;</a:t>
             </a:fld>
             <a:endParaRPr lang="en-US" altLang="ja-JP"/>
           </a:p>
@@ -2355,12 +2339,12 @@
             <a:pPr>
               <a:defRPr/>
             </a:pPr>
-            <a:fld id="{AB639D15-124E-453B-9476-1C699AB43B7C}" type="slidenum">
+            <a:fld id="{CC0EE0EF-6E22-4DC2-88C0-A1C53D9ADFC2}" type="slidenum">
               <a:rPr lang="en-US" altLang="ja-JP"/>
               <a:pPr>
                 <a:defRPr/>
               </a:pPr>
-              <a:t>‹#›</a:t>
+              <a:t>&lt;#&gt;</a:t>
             </a:fld>
             <a:endParaRPr lang="en-US" altLang="ja-JP"/>
           </a:p>
@@ -2683,12 +2667,12 @@
             <a:pPr>
               <a:defRPr/>
             </a:pPr>
-            <a:fld id="{AEC43CB1-7A21-4E65-8520-9ACDFA1FF5AA}" type="slidenum">
+            <a:fld id="{62CECB2D-827F-4AAA-85CE-EDE948CD1E7F}" type="slidenum">
               <a:rPr lang="en-US" altLang="ja-JP"/>
               <a:pPr>
                 <a:defRPr/>
               </a:pPr>
-              <a:t>‹#›</a:t>
+              <a:t>&lt;#&gt;</a:t>
             </a:fld>
             <a:endParaRPr lang="en-US" altLang="ja-JP"/>
           </a:p>
@@ -2957,12 +2941,12 @@
             <a:pPr>
               <a:defRPr/>
             </a:pPr>
-            <a:fld id="{CD10CC73-0D5D-4B16-AC5C-175440223A67}" type="slidenum">
+            <a:fld id="{8EF73FFC-F6DF-4431-8BCF-69D9F1D7717B}" type="slidenum">
               <a:rPr lang="en-US" altLang="ja-JP"/>
               <a:pPr>
                 <a:defRPr/>
               </a:pPr>
-              <a:t>‹#›</a:t>
+              <a:t>&lt;#&gt;</a:t>
             </a:fld>
             <a:endParaRPr lang="en-US" altLang="ja-JP"/>
           </a:p>
@@ -3037,7 +3021,7 @@
           <a:p>
             <a:pPr lvl="0"/>
             <a:r>
-              <a:rPr lang="ja-JP" altLang="en-US"/>
+              <a:rPr lang="ja-JP" altLang="en-US" smtClean="0"/>
               <a:t>マスタ タイトルの書式設定</a:t>
             </a:r>
           </a:p>
@@ -3079,67 +3063,67 @@
           <a:p>
             <a:pPr lvl="0"/>
             <a:r>
-              <a:rPr lang="ja-JP" altLang="en-US"/>
+              <a:rPr lang="ja-JP" altLang="en-US" smtClean="0"/>
               <a:t>マスタ テキストの書式設定</a:t>
             </a:r>
           </a:p>
           <a:p>
             <a:pPr lvl="1"/>
             <a:r>
-              <a:rPr lang="ja-JP" altLang="en-US"/>
+              <a:rPr lang="ja-JP" altLang="en-US" smtClean="0"/>
               <a:t>第 </a:t>
             </a:r>
             <a:r>
-              <a:rPr lang="en-US" altLang="ja-JP"/>
+              <a:rPr lang="en-US" altLang="ja-JP" smtClean="0"/>
               <a:t>2 </a:t>
             </a:r>
             <a:r>
-              <a:rPr lang="ja-JP" altLang="en-US"/>
+              <a:rPr lang="ja-JP" altLang="en-US" smtClean="0"/>
               <a:t>レベル</a:t>
             </a:r>
           </a:p>
           <a:p>
             <a:pPr lvl="2"/>
             <a:r>
-              <a:rPr lang="ja-JP" altLang="en-US"/>
+              <a:rPr lang="ja-JP" altLang="en-US" smtClean="0"/>
               <a:t>第 </a:t>
             </a:r>
             <a:r>
-              <a:rPr lang="en-US" altLang="ja-JP"/>
+              <a:rPr lang="en-US" altLang="ja-JP" smtClean="0"/>
               <a:t>3 </a:t>
             </a:r>
             <a:r>
-              <a:rPr lang="ja-JP" altLang="en-US"/>
+              <a:rPr lang="ja-JP" altLang="en-US" smtClean="0"/>
               <a:t>レベル</a:t>
             </a:r>
           </a:p>
           <a:p>
             <a:pPr lvl="3"/>
             <a:r>
-              <a:rPr lang="ja-JP" altLang="en-US"/>
+              <a:rPr lang="ja-JP" altLang="en-US" smtClean="0"/>
               <a:t>第 </a:t>
             </a:r>
             <a:r>
-              <a:rPr lang="en-US" altLang="ja-JP"/>
+              <a:rPr lang="en-US" altLang="ja-JP" smtClean="0"/>
               <a:t>4 </a:t>
             </a:r>
             <a:r>
-              <a:rPr lang="ja-JP" altLang="en-US"/>
+              <a:rPr lang="ja-JP" altLang="en-US" smtClean="0"/>
               <a:t>レベル</a:t>
             </a:r>
           </a:p>
           <a:p>
             <a:pPr lvl="4"/>
             <a:r>
-              <a:rPr lang="ja-JP" altLang="en-US"/>
+              <a:rPr lang="ja-JP" altLang="en-US" smtClean="0"/>
               <a:t>第 </a:t>
             </a:r>
             <a:r>
-              <a:rPr lang="en-US" altLang="ja-JP"/>
+              <a:rPr lang="en-US" altLang="ja-JP" smtClean="0"/>
               <a:t>5 </a:t>
             </a:r>
             <a:r>
-              <a:rPr lang="ja-JP" altLang="en-US"/>
+              <a:rPr lang="ja-JP" altLang="en-US" smtClean="0"/>
               <a:t>レベル</a:t>
             </a:r>
           </a:p>
@@ -3279,12 +3263,12 @@
             <a:pPr>
               <a:defRPr/>
             </a:pPr>
-            <a:fld id="{6449E0DD-A121-4D5A-B007-386C0392C0D0}" type="slidenum">
+            <a:fld id="{34109229-DE83-4AA3-93C9-7B2D148FA0D2}" type="slidenum">
               <a:rPr lang="en-US" altLang="ja-JP"/>
               <a:pPr>
                 <a:defRPr/>
               </a:pPr>
-              <a:t>‹#›</a:t>
+              <a:t>&lt;#&gt;</a:t>
             </a:fld>
             <a:endParaRPr lang="en-US" altLang="ja-JP"/>
           </a:p>
@@ -3294,17 +3278,17 @@
   </p:cSld>
   <p:clrMap bg1="lt1" tx1="dk1" bg2="lt2" tx2="dk2" accent1="accent1" accent2="accent2" accent3="accent3" accent4="accent4" accent5="accent5" accent6="accent6" hlink="hlink" folHlink="folHlink"/>
   <p:sldLayoutIdLst>
-    <p:sldLayoutId id="2147483659" r:id="rId1"/>
-    <p:sldLayoutId id="2147483658" r:id="rId2"/>
-    <p:sldLayoutId id="2147483657" r:id="rId3"/>
-    <p:sldLayoutId id="2147483656" r:id="rId4"/>
-    <p:sldLayoutId id="2147483655" r:id="rId5"/>
+    <p:sldLayoutId id="2147483649" r:id="rId1"/>
+    <p:sldLayoutId id="2147483650" r:id="rId2"/>
+    <p:sldLayoutId id="2147483651" r:id="rId3"/>
+    <p:sldLayoutId id="2147483652" r:id="rId4"/>
+    <p:sldLayoutId id="2147483653" r:id="rId5"/>
     <p:sldLayoutId id="2147483654" r:id="rId6"/>
-    <p:sldLayoutId id="2147483653" r:id="rId7"/>
-    <p:sldLayoutId id="2147483652" r:id="rId8"/>
-    <p:sldLayoutId id="2147483651" r:id="rId9"/>
-    <p:sldLayoutId id="2147483650" r:id="rId10"/>
-    <p:sldLayoutId id="2147483649" r:id="rId11"/>
+    <p:sldLayoutId id="2147483655" r:id="rId7"/>
+    <p:sldLayoutId id="2147483656" r:id="rId8"/>
+    <p:sldLayoutId id="2147483657" r:id="rId9"/>
+    <p:sldLayoutId id="2147483658" r:id="rId10"/>
+    <p:sldLayoutId id="2147483659" r:id="rId11"/>
   </p:sldLayoutIdLst>
   <p:txStyles>
     <p:titleStyle>
@@ -3710,7 +3694,7 @@
       </p:grpSpPr>
       <p:grpSp>
         <p:nvGrpSpPr>
-          <p:cNvPr id="16390" name="Group 6"/>
+          <p:cNvPr id="13313" name="Group 6"/>
           <p:cNvGrpSpPr>
             <a:grpSpLocks/>
           </p:cNvGrpSpPr>
@@ -3726,7 +3710,7 @@
         </p:grpSpPr>
         <p:pic>
           <p:nvPicPr>
-            <p:cNvPr id="16388" name="Picture 4"/>
+            <p:cNvPr id="13339" name="Picture 4"/>
             <p:cNvPicPr>
               <a:picLocks noChangeAspect="1" noChangeArrowheads="1"/>
             </p:cNvPicPr>
@@ -3754,12 +3738,11 @@
               <a:headEnd/>
               <a:tailEnd/>
             </a:ln>
-            <a:effectLst/>
           </p:spPr>
         </p:pic>
         <p:sp>
           <p:nvSpPr>
-            <p:cNvPr id="16389" name="Rectangle 5"/>
+            <p:cNvPr id="13340" name="Rectangle 5"/>
             <p:cNvSpPr>
               <a:spLocks noChangeArrowheads="1"/>
             </p:cNvSpPr>
@@ -3796,7 +3779,7 @@
       </p:grpSp>
       <p:sp>
         <p:nvSpPr>
-          <p:cNvPr id="16392" name="Rectangle 7"/>
+          <p:cNvPr id="13314" name="Rectangle 7"/>
           <p:cNvSpPr>
             <a:spLocks noChangeArrowheads="1"/>
           </p:cNvSpPr>
@@ -3836,7 +3819,7 @@
       </p:sp>
       <p:sp>
         <p:nvSpPr>
-          <p:cNvPr id="16394" name="Rectangle 9"/>
+          <p:cNvPr id="13315" name="Rectangle 9"/>
           <p:cNvSpPr>
             <a:spLocks noChangeArrowheads="1"/>
           </p:cNvSpPr>
@@ -3876,7 +3859,7 @@
       </p:sp>
       <p:sp>
         <p:nvSpPr>
-          <p:cNvPr id="16395" name="Rectangle 10"/>
+          <p:cNvPr id="13316" name="Rectangle 10"/>
           <p:cNvSpPr>
             <a:spLocks noChangeArrowheads="1"/>
           </p:cNvSpPr>
@@ -3916,7 +3899,7 @@
       </p:sp>
       <p:sp>
         <p:nvSpPr>
-          <p:cNvPr id="16396" name="Rectangle 11"/>
+          <p:cNvPr id="13317" name="Rectangle 11"/>
           <p:cNvSpPr>
             <a:spLocks noChangeArrowheads="1"/>
           </p:cNvSpPr>
@@ -3956,7 +3939,7 @@
       </p:sp>
       <p:sp>
         <p:nvSpPr>
-          <p:cNvPr id="16397" name="Rectangle 12"/>
+          <p:cNvPr id="13318" name="Rectangle 12"/>
           <p:cNvSpPr>
             <a:spLocks noChangeArrowheads="1"/>
           </p:cNvSpPr>
@@ -3996,7 +3979,7 @@
       </p:sp>
       <p:sp>
         <p:nvSpPr>
-          <p:cNvPr id="16400" name="Rectangle 15"/>
+          <p:cNvPr id="13319" name="Rectangle 15"/>
           <p:cNvSpPr>
             <a:spLocks noChangeArrowheads="1"/>
           </p:cNvSpPr>
@@ -4036,14 +4019,14 @@
       </p:sp>
       <p:sp>
         <p:nvSpPr>
-          <p:cNvPr id="16401" name="Rectangle 16"/>
+          <p:cNvPr id="13320" name="Rectangle 16"/>
           <p:cNvSpPr>
             <a:spLocks noChangeArrowheads="1"/>
           </p:cNvSpPr>
           <p:nvPr/>
         </p:nvSpPr>
         <p:spPr bwMode="auto">
-          <a:xfrm rot="-21600000">
+          <a:xfrm>
             <a:off x="7315200" y="3535363"/>
             <a:ext cx="358775" cy="112712"/>
           </a:xfrm>
@@ -4076,14 +4059,14 @@
       </p:sp>
       <p:sp>
         <p:nvSpPr>
-          <p:cNvPr id="16402" name="Rectangle 17"/>
+          <p:cNvPr id="13321" name="Rectangle 17"/>
           <p:cNvSpPr>
             <a:spLocks noChangeArrowheads="1"/>
           </p:cNvSpPr>
           <p:nvPr/>
         </p:nvSpPr>
         <p:spPr bwMode="auto">
-          <a:xfrm rot="-21600000">
+          <a:xfrm>
             <a:off x="7308850" y="4378325"/>
             <a:ext cx="358775" cy="112713"/>
           </a:xfrm>
@@ -4116,7 +4099,7 @@
       </p:sp>
       <p:sp>
         <p:nvSpPr>
-          <p:cNvPr id="16404" name="Rectangle 19"/>
+          <p:cNvPr id="13322" name="Rectangle 19"/>
           <p:cNvSpPr>
             <a:spLocks noChangeArrowheads="1"/>
           </p:cNvSpPr>
@@ -4156,7 +4139,7 @@
       </p:sp>
       <p:sp>
         <p:nvSpPr>
-          <p:cNvPr id="16405" name="Rectangle 6"/>
+          <p:cNvPr id="13323" name="Rectangle 6"/>
           <p:cNvSpPr>
             <a:spLocks noChangeArrowheads="1"/>
           </p:cNvSpPr>
@@ -4196,7 +4179,7 @@
       </p:sp>
       <p:sp>
         <p:nvSpPr>
-          <p:cNvPr id="16406" name="Rectangle 9"/>
+          <p:cNvPr id="13324" name="Rectangle 9"/>
           <p:cNvSpPr>
             <a:spLocks noChangeArrowheads="1"/>
           </p:cNvSpPr>
@@ -4236,7 +4219,7 @@
       </p:sp>
       <p:sp>
         <p:nvSpPr>
-          <p:cNvPr id="16407" name="Rectangle 19"/>
+          <p:cNvPr id="13325" name="Rectangle 19"/>
           <p:cNvSpPr>
             <a:spLocks noChangeArrowheads="1"/>
           </p:cNvSpPr>
@@ -4276,7 +4259,7 @@
       </p:sp>
       <p:sp>
         <p:nvSpPr>
-          <p:cNvPr id="16408" name="Rectangle 15"/>
+          <p:cNvPr id="13326" name="Rectangle 15"/>
           <p:cNvSpPr>
             <a:spLocks noChangeArrowheads="1"/>
           </p:cNvSpPr>
@@ -4316,7 +4299,7 @@
       </p:sp>
       <p:sp>
         <p:nvSpPr>
-          <p:cNvPr id="16409" name="Rectangle 12"/>
+          <p:cNvPr id="13327" name="Rectangle 12"/>
           <p:cNvSpPr>
             <a:spLocks noChangeArrowheads="1"/>
           </p:cNvSpPr>
@@ -4356,7 +4339,7 @@
       </p:sp>
       <p:sp>
         <p:nvSpPr>
-          <p:cNvPr id="16410" name="Rectangle 12"/>
+          <p:cNvPr id="13328" name="Rectangle 12"/>
           <p:cNvSpPr>
             <a:spLocks noChangeArrowheads="1"/>
           </p:cNvSpPr>
@@ -4396,7 +4379,7 @@
       </p:sp>
       <p:sp>
         <p:nvSpPr>
-          <p:cNvPr id="16411" name="Rectangle 12"/>
+          <p:cNvPr id="13329" name="Rectangle 12"/>
           <p:cNvSpPr>
             <a:spLocks noChangeArrowheads="1"/>
           </p:cNvSpPr>
@@ -4436,16 +4419,16 @@
       </p:sp>
       <p:sp>
         <p:nvSpPr>
-          <p:cNvPr id="16412" name="Rectangle 12"/>
+          <p:cNvPr id="13330" name="Rectangle 12"/>
           <p:cNvSpPr>
             <a:spLocks noChangeArrowheads="1"/>
           </p:cNvSpPr>
           <p:nvPr/>
         </p:nvSpPr>
         <p:spPr bwMode="auto">
-          <a:xfrm rot="-21600000">
-            <a:off x="7843838" y="2627313"/>
-            <a:ext cx="209550" cy="112712"/>
+          <a:xfrm>
+            <a:off x="7766050" y="2624138"/>
+            <a:ext cx="360363" cy="112712"/>
           </a:xfrm>
           <a:prstGeom prst="rect">
             <a:avLst/>
@@ -4469,14 +4452,14 @@
             <a:pPr algn="ctr"/>
             <a:r>
               <a:rPr lang="en-US" altLang="ja-JP" sz="800"/>
-              <a:t>0.4A</a:t>
-            </a:r>
-          </a:p>
-        </p:txBody>
-      </p:sp>
-      <p:sp>
-        <p:nvSpPr>
-          <p:cNvPr id="16413" name="Rectangle 9"/>
+              <a:t>Jumper</a:t>
+            </a:r>
+          </a:p>
+        </p:txBody>
+      </p:sp>
+      <p:sp>
+        <p:nvSpPr>
+          <p:cNvPr id="13331" name="Rectangle 9"/>
           <p:cNvSpPr>
             <a:spLocks noChangeArrowheads="1"/>
           </p:cNvSpPr>
@@ -4516,7 +4499,7 @@
       </p:sp>
       <p:sp>
         <p:nvSpPr>
-          <p:cNvPr id="16414" name="Rectangle 9"/>
+          <p:cNvPr id="13332" name="Rectangle 9"/>
           <p:cNvSpPr>
             <a:spLocks noChangeArrowheads="1"/>
           </p:cNvSpPr>
@@ -4556,7 +4539,7 @@
       </p:sp>
       <p:sp>
         <p:nvSpPr>
-          <p:cNvPr id="16415" name="Oval 31"/>
+          <p:cNvPr id="13333" name="Oval 31"/>
           <p:cNvSpPr>
             <a:spLocks noChangeArrowheads="1"/>
           </p:cNvSpPr>
@@ -4581,7 +4564,6 @@
             <a:headEnd/>
             <a:tailEnd/>
           </a:ln>
-          <a:effectLst/>
         </p:spPr>
         <p:txBody>
           <a:bodyPr wrap="none" anchor="ctr"/>
@@ -4597,7 +4579,7 @@
       </p:sp>
       <p:sp>
         <p:nvSpPr>
-          <p:cNvPr id="16417" name="Oval 33"/>
+          <p:cNvPr id="13334" name="Oval 33"/>
           <p:cNvSpPr>
             <a:spLocks noChangeArrowheads="1"/>
           </p:cNvSpPr>
@@ -4622,7 +4604,6 @@
             <a:headEnd/>
             <a:tailEnd/>
           </a:ln>
-          <a:effectLst/>
         </p:spPr>
         <p:txBody>
           <a:bodyPr wrap="none" anchor="ctr"/>
@@ -4638,7 +4619,7 @@
       </p:sp>
       <p:sp>
         <p:nvSpPr>
-          <p:cNvPr id="16418" name="Oval 34"/>
+          <p:cNvPr id="13335" name="Oval 34"/>
           <p:cNvSpPr>
             <a:spLocks noChangeArrowheads="1"/>
           </p:cNvSpPr>
@@ -4663,7 +4644,6 @@
             <a:headEnd/>
             <a:tailEnd/>
           </a:ln>
-          <a:effectLst/>
         </p:spPr>
         <p:txBody>
           <a:bodyPr wrap="none" anchor="ctr"/>
@@ -4679,7 +4659,7 @@
       </p:sp>
       <p:sp>
         <p:nvSpPr>
-          <p:cNvPr id="16419" name="Oval 35"/>
+          <p:cNvPr id="13336" name="Oval 35"/>
           <p:cNvSpPr>
             <a:spLocks noChangeArrowheads="1"/>
           </p:cNvSpPr>
@@ -4704,7 +4684,6 @@
             <a:headEnd/>
             <a:tailEnd/>
           </a:ln>
-          <a:effectLst/>
         </p:spPr>
         <p:txBody>
           <a:bodyPr wrap="none" anchor="ctr"/>
@@ -4720,7 +4699,7 @@
       </p:sp>
       <p:sp>
         <p:nvSpPr>
-          <p:cNvPr id="16420" name="Text Box 36"/>
+          <p:cNvPr id="13337" name="Text Box 36"/>
           <p:cNvSpPr txBox="1">
             <a:spLocks noChangeArrowheads="1"/>
           </p:cNvSpPr>
@@ -4729,7 +4708,7 @@
         <p:spPr bwMode="auto">
           <a:xfrm>
             <a:off x="0" y="0"/>
-            <a:ext cx="924356" cy="369332"/>
+            <a:ext cx="923925" cy="369888"/>
           </a:xfrm>
           <a:prstGeom prst="rect">
             <a:avLst/>
@@ -4741,7 +4720,6 @@
             <a:headEnd/>
             <a:tailEnd/>
           </a:ln>
-          <a:effectLst/>
         </p:spPr>
         <p:txBody>
           <a:bodyPr wrap="none">
@@ -4750,7 +4728,7 @@
           <a:lstStyle/>
           <a:p>
             <a:r>
-              <a:rPr lang="en-US" altLang="ja-JP" dirty="0"/>
+              <a:rPr lang="en-US" altLang="ja-JP"/>
               <a:t>UNIT A</a:t>
             </a:r>
           </a:p>
@@ -4758,13 +4736,7 @@
       </p:sp>
       <p:sp>
         <p:nvSpPr>
-          <p:cNvPr id="2" name="Oval 35">
-            <a:extLst>
-              <a:ext uri="{FF2B5EF4-FFF2-40B4-BE49-F238E27FC236}">
-                <a16:creationId xmlns:a16="http://schemas.microsoft.com/office/drawing/2014/main" id="{70B87310-AC77-564B-4DF1-50D3250B61B5}"/>
-              </a:ext>
-            </a:extLst>
-          </p:cNvPr>
+          <p:cNvPr id="13338" name="Oval 35"/>
           <p:cNvSpPr>
             <a:spLocks noChangeArrowheads="1"/>
           </p:cNvSpPr>
@@ -4789,7 +4761,6 @@
             <a:headEnd/>
             <a:tailEnd/>
           </a:ln>
-          <a:effectLst/>
         </p:spPr>
         <p:txBody>
           <a:bodyPr wrap="none" anchor="ctr"/>
@@ -4797,7 +4768,7 @@
           <a:p>
             <a:pPr algn="ctr"/>
             <a:r>
-              <a:rPr lang="en-US" altLang="ja-JP" sz="800" dirty="0"/>
+              <a:rPr lang="en-US" altLang="ja-JP" sz="800"/>
               <a:t>1F</a:t>
             </a:r>
           </a:p>
@@ -4846,7 +4817,7 @@
         </p:grpSpPr>
         <p:pic>
           <p:nvPicPr>
-            <p:cNvPr id="14373" name="Picture 4"/>
+            <p:cNvPr id="14403" name="Picture 4"/>
             <p:cNvPicPr>
               <a:picLocks noChangeAspect="1" noChangeArrowheads="1"/>
             </p:cNvPicPr>
@@ -4878,7 +4849,7 @@
         </p:pic>
         <p:sp>
           <p:nvSpPr>
-            <p:cNvPr id="14374" name="Rectangle 5"/>
+            <p:cNvPr id="14404" name="Rectangle 5"/>
             <p:cNvSpPr>
               <a:spLocks noChangeArrowheads="1"/>
             </p:cNvSpPr>
@@ -6386,7 +6357,7 @@
       </p:sp>
       <p:sp>
         <p:nvSpPr>
-          <p:cNvPr id="14376" name="Text Box 40"/>
+          <p:cNvPr id="14373" name="Text Box 40"/>
           <p:cNvSpPr txBox="1">
             <a:spLocks noChangeArrowheads="1"/>
           </p:cNvSpPr>
@@ -6395,7 +6366,7 @@
         <p:spPr bwMode="auto">
           <a:xfrm>
             <a:off x="0" y="0"/>
-            <a:ext cx="937116" cy="369332"/>
+            <a:ext cx="936625" cy="369888"/>
           </a:xfrm>
           <a:prstGeom prst="rect">
             <a:avLst/>
@@ -6407,7 +6378,6 @@
             <a:headEnd/>
             <a:tailEnd/>
           </a:ln>
-          <a:effectLst/>
         </p:spPr>
         <p:txBody>
           <a:bodyPr wrap="none">
@@ -6416,7 +6386,7 @@
           <a:lstStyle/>
           <a:p>
             <a:r>
-              <a:rPr lang="en-US" altLang="ja-JP" dirty="0"/>
+              <a:rPr lang="en-US" altLang="ja-JP"/>
               <a:t>UNIT B</a:t>
             </a:r>
           </a:p>
@@ -6424,7 +6394,7 @@
       </p:sp>
       <p:sp>
         <p:nvSpPr>
-          <p:cNvPr id="14377" name="Rectangle 32"/>
+          <p:cNvPr id="14374" name="Rectangle 32"/>
           <p:cNvSpPr>
             <a:spLocks noChangeArrowheads="1"/>
           </p:cNvSpPr>
@@ -6464,7 +6434,7 @@
       </p:sp>
       <p:sp>
         <p:nvSpPr>
-          <p:cNvPr id="14378" name="Rectangle 9"/>
+          <p:cNvPr id="14375" name="Rectangle 9"/>
           <p:cNvSpPr>
             <a:spLocks noChangeArrowheads="1"/>
           </p:cNvSpPr>
@@ -6511,7 +6481,7 @@
       </p:sp>
       <p:sp>
         <p:nvSpPr>
-          <p:cNvPr id="14379" name="Rectangle 9"/>
+          <p:cNvPr id="14376" name="Rectangle 9"/>
           <p:cNvSpPr>
             <a:spLocks noChangeArrowheads="1"/>
           </p:cNvSpPr>
@@ -6558,7 +6528,7 @@
       </p:sp>
       <p:sp>
         <p:nvSpPr>
-          <p:cNvPr id="14380" name="Rectangle 9"/>
+          <p:cNvPr id="14377" name="Rectangle 9"/>
           <p:cNvSpPr>
             <a:spLocks noChangeArrowheads="1"/>
           </p:cNvSpPr>
@@ -6605,33 +6575,23 @@
       </p:sp>
       <p:grpSp>
         <p:nvGrpSpPr>
-          <p:cNvPr id="11" name="グループ化 10">
-            <a:extLst>
-              <a:ext uri="{FF2B5EF4-FFF2-40B4-BE49-F238E27FC236}">
-                <a16:creationId xmlns:a16="http://schemas.microsoft.com/office/drawing/2014/main" id="{52055071-A7E1-6AB5-8489-DA1E8D60B4E1}"/>
-              </a:ext>
-            </a:extLst>
-          </p:cNvPr>
-          <p:cNvGrpSpPr/>
+          <p:cNvPr id="14378" name="グループ化 10"/>
+          <p:cNvGrpSpPr>
+            <a:grpSpLocks/>
+          </p:cNvGrpSpPr>
           <p:nvPr/>
         </p:nvGrpSpPr>
-        <p:grpSpPr>
+        <p:grpSpPr bwMode="auto">
           <a:xfrm>
-            <a:off x="7136384" y="790575"/>
-            <a:ext cx="96838" cy="268288"/>
+            <a:off x="7135813" y="790575"/>
+            <a:ext cx="96837" cy="268288"/>
             <a:chOff x="6829997" y="159544"/>
             <a:chExt cx="96838" cy="268288"/>
           </a:xfrm>
         </p:grpSpPr>
         <p:sp>
           <p:nvSpPr>
-            <p:cNvPr id="9" name="Rectangle 40">
-              <a:extLst>
-                <a:ext uri="{FF2B5EF4-FFF2-40B4-BE49-F238E27FC236}">
-                  <a16:creationId xmlns:a16="http://schemas.microsoft.com/office/drawing/2014/main" id="{BC3D39D0-0F07-DA7D-AA9A-C0F64B0D4EC3}"/>
-                </a:ext>
-              </a:extLst>
-            </p:cNvPr>
+            <p:cNvPr id="14399" name="Rectangle 40"/>
             <p:cNvSpPr>
               <a:spLocks noChangeArrowheads="1"/>
             </p:cNvSpPr>
@@ -6662,7 +6622,7 @@
             <a:lstStyle/>
             <a:p>
               <a:pPr algn="ctr"/>
-              <a:endParaRPr lang="ja-JP" altLang="en-US" sz="800" dirty="0"/>
+              <a:endParaRPr lang="ja-JP" altLang="en-US" sz="800"/>
             </a:p>
           </p:txBody>
         </p:sp>
@@ -6670,9 +6630,7 @@
           <p:nvSpPr>
             <p:cNvPr id="2" name="二等辺三角形 1">
               <a:extLst>
-                <a:ext uri="{FF2B5EF4-FFF2-40B4-BE49-F238E27FC236}">
-                  <a16:creationId xmlns:a16="http://schemas.microsoft.com/office/drawing/2014/main" id="{D55D1BB4-3DF6-B4EA-2BC9-956846489E21}"/>
-                </a:ext>
+                <a:ext uri="{FF2B5EF4-FFF2-40B4-BE49-F238E27FC236}"/>
               </a:extLst>
             </p:cNvPr>
             <p:cNvSpPr/>
@@ -6680,8 +6638,8 @@
           </p:nvSpPr>
           <p:spPr>
             <a:xfrm>
-              <a:off x="6844060" y="226504"/>
-              <a:ext cx="72008" cy="135285"/>
+              <a:off x="6844284" y="226219"/>
+              <a:ext cx="71439" cy="134938"/>
             </a:xfrm>
             <a:prstGeom prst="triangle">
               <a:avLst/>
@@ -6709,11 +6667,13 @@
             </a:fontRef>
           </p:style>
           <p:txBody>
-            <a:bodyPr rtlCol="0" anchor="ctr"/>
+            <a:bodyPr anchor="ctr"/>
             <a:lstStyle/>
             <a:p>
-              <a:pPr algn="ctr"/>
-              <a:endParaRPr kumimoji="1" lang="ja-JP" altLang="en-US" dirty="0"/>
+              <a:pPr algn="ctr">
+                <a:defRPr/>
+              </a:pPr>
+              <a:endParaRPr lang="ja-JP" altLang="en-US" dirty="0"/>
             </a:p>
           </p:txBody>
         </p:sp>
@@ -6721,9 +6681,7 @@
           <p:nvCxnSpPr>
             <p:cNvPr id="4" name="直線コネクタ 3">
               <a:extLst>
-                <a:ext uri="{FF2B5EF4-FFF2-40B4-BE49-F238E27FC236}">
-                  <a16:creationId xmlns:a16="http://schemas.microsoft.com/office/drawing/2014/main" id="{8B922520-67D2-96D2-76F7-C65845F57A29}"/>
-                </a:ext>
+                <a:ext uri="{FF2B5EF4-FFF2-40B4-BE49-F238E27FC236}"/>
               </a:extLst>
             </p:cNvPr>
             <p:cNvCxnSpPr>
@@ -6733,8 +6691,8 @@
           </p:nvCxnSpPr>
           <p:spPr>
             <a:xfrm>
-              <a:off x="6879035" y="183356"/>
-              <a:ext cx="0" cy="218741"/>
+              <a:off x="6879210" y="183357"/>
+              <a:ext cx="0" cy="219075"/>
             </a:xfrm>
             <a:prstGeom prst="line">
               <a:avLst/>
@@ -6764,9 +6722,7 @@
           <p:nvCxnSpPr>
             <p:cNvPr id="6" name="直線コネクタ 5">
               <a:extLst>
-                <a:ext uri="{FF2B5EF4-FFF2-40B4-BE49-F238E27FC236}">
-                  <a16:creationId xmlns:a16="http://schemas.microsoft.com/office/drawing/2014/main" id="{BDCA3E0E-D4A3-2638-E10A-29D1C5F1AD79}"/>
-                </a:ext>
+                <a:ext uri="{FF2B5EF4-FFF2-40B4-BE49-F238E27FC236}"/>
               </a:extLst>
             </p:cNvPr>
             <p:cNvCxnSpPr/>
@@ -6774,8 +6730,8 @@
           </p:nvCxnSpPr>
           <p:spPr>
             <a:xfrm>
-              <a:off x="6841679" y="226504"/>
-              <a:ext cx="72008" cy="0"/>
+              <a:off x="6841109" y="226219"/>
+              <a:ext cx="73026" cy="0"/>
             </a:xfrm>
             <a:prstGeom prst="line">
               <a:avLst/>
@@ -6804,33 +6760,23 @@
       </p:grpSp>
       <p:grpSp>
         <p:nvGrpSpPr>
-          <p:cNvPr id="12" name="グループ化 11">
-            <a:extLst>
-              <a:ext uri="{FF2B5EF4-FFF2-40B4-BE49-F238E27FC236}">
-                <a16:creationId xmlns:a16="http://schemas.microsoft.com/office/drawing/2014/main" id="{B5486697-0A65-DD5B-B2AD-D82A9576DD20}"/>
-              </a:ext>
-            </a:extLst>
-          </p:cNvPr>
-          <p:cNvGrpSpPr/>
+          <p:cNvPr id="14379" name="グループ化 11"/>
+          <p:cNvGrpSpPr>
+            <a:grpSpLocks/>
+          </p:cNvGrpSpPr>
           <p:nvPr/>
         </p:nvGrpSpPr>
-        <p:grpSpPr>
+        <p:grpSpPr bwMode="auto">
           <a:xfrm>
-            <a:off x="7332440" y="781051"/>
-            <a:ext cx="96838" cy="268288"/>
+            <a:off x="7332663" y="781050"/>
+            <a:ext cx="96837" cy="268288"/>
             <a:chOff x="6829997" y="159544"/>
             <a:chExt cx="96838" cy="268288"/>
           </a:xfrm>
         </p:grpSpPr>
         <p:sp>
           <p:nvSpPr>
-            <p:cNvPr id="13" name="Rectangle 40">
-              <a:extLst>
-                <a:ext uri="{FF2B5EF4-FFF2-40B4-BE49-F238E27FC236}">
-                  <a16:creationId xmlns:a16="http://schemas.microsoft.com/office/drawing/2014/main" id="{DD2BCCB0-7530-1407-58DF-500945402136}"/>
-                </a:ext>
-              </a:extLst>
-            </p:cNvPr>
+            <p:cNvPr id="14395" name="Rectangle 40"/>
             <p:cNvSpPr>
               <a:spLocks noChangeArrowheads="1"/>
             </p:cNvSpPr>
@@ -6861,7 +6807,7 @@
             <a:lstStyle/>
             <a:p>
               <a:pPr algn="ctr"/>
-              <a:endParaRPr lang="ja-JP" altLang="en-US" sz="800" dirty="0"/>
+              <a:endParaRPr lang="ja-JP" altLang="en-US" sz="800"/>
             </a:p>
           </p:txBody>
         </p:sp>
@@ -6869,9 +6815,7 @@
           <p:nvSpPr>
             <p:cNvPr id="14" name="二等辺三角形 13">
               <a:extLst>
-                <a:ext uri="{FF2B5EF4-FFF2-40B4-BE49-F238E27FC236}">
-                  <a16:creationId xmlns:a16="http://schemas.microsoft.com/office/drawing/2014/main" id="{96931585-D468-61AC-F68D-C1E81DD01245}"/>
-                </a:ext>
+                <a:ext uri="{FF2B5EF4-FFF2-40B4-BE49-F238E27FC236}"/>
               </a:extLst>
             </p:cNvPr>
             <p:cNvSpPr/>
@@ -6879,8 +6823,8 @@
           </p:nvSpPr>
           <p:spPr>
             <a:xfrm>
-              <a:off x="6844060" y="226504"/>
-              <a:ext cx="72008" cy="135285"/>
+              <a:off x="6844284" y="226219"/>
+              <a:ext cx="71439" cy="134938"/>
             </a:xfrm>
             <a:prstGeom prst="triangle">
               <a:avLst/>
@@ -6908,11 +6852,13 @@
             </a:fontRef>
           </p:style>
           <p:txBody>
-            <a:bodyPr rtlCol="0" anchor="ctr"/>
+            <a:bodyPr anchor="ctr"/>
             <a:lstStyle/>
             <a:p>
-              <a:pPr algn="ctr"/>
-              <a:endParaRPr kumimoji="1" lang="ja-JP" altLang="en-US" dirty="0"/>
+              <a:pPr algn="ctr">
+                <a:defRPr/>
+              </a:pPr>
+              <a:endParaRPr lang="ja-JP" altLang="en-US" dirty="0"/>
             </a:p>
           </p:txBody>
         </p:sp>
@@ -6920,9 +6866,7 @@
           <p:nvCxnSpPr>
             <p:cNvPr id="15" name="直線コネクタ 14">
               <a:extLst>
-                <a:ext uri="{FF2B5EF4-FFF2-40B4-BE49-F238E27FC236}">
-                  <a16:creationId xmlns:a16="http://schemas.microsoft.com/office/drawing/2014/main" id="{DEF70C6E-57D2-A6FC-2CFD-484C4BC7BCB5}"/>
-                </a:ext>
+                <a:ext uri="{FF2B5EF4-FFF2-40B4-BE49-F238E27FC236}"/>
               </a:extLst>
             </p:cNvPr>
             <p:cNvCxnSpPr>
@@ -6932,8 +6876,8 @@
           </p:nvCxnSpPr>
           <p:spPr>
             <a:xfrm>
-              <a:off x="6879035" y="183356"/>
-              <a:ext cx="0" cy="218741"/>
+              <a:off x="6879210" y="183357"/>
+              <a:ext cx="0" cy="219075"/>
             </a:xfrm>
             <a:prstGeom prst="line">
               <a:avLst/>
@@ -6963,9 +6907,7 @@
           <p:nvCxnSpPr>
             <p:cNvPr id="16" name="直線コネクタ 15">
               <a:extLst>
-                <a:ext uri="{FF2B5EF4-FFF2-40B4-BE49-F238E27FC236}">
-                  <a16:creationId xmlns:a16="http://schemas.microsoft.com/office/drawing/2014/main" id="{45545202-E70E-0C26-7D9D-0FC9B061DBBB}"/>
-                </a:ext>
+                <a:ext uri="{FF2B5EF4-FFF2-40B4-BE49-F238E27FC236}"/>
               </a:extLst>
             </p:cNvPr>
             <p:cNvCxnSpPr/>
@@ -6973,8 +6915,8 @@
           </p:nvCxnSpPr>
           <p:spPr>
             <a:xfrm>
-              <a:off x="6841679" y="226504"/>
-              <a:ext cx="72008" cy="0"/>
+              <a:off x="6841109" y="226219"/>
+              <a:ext cx="73026" cy="0"/>
             </a:xfrm>
             <a:prstGeom prst="line">
               <a:avLst/>
@@ -7003,33 +6945,23 @@
       </p:grpSp>
       <p:grpSp>
         <p:nvGrpSpPr>
-          <p:cNvPr id="17" name="グループ化 16">
-            <a:extLst>
-              <a:ext uri="{FF2B5EF4-FFF2-40B4-BE49-F238E27FC236}">
-                <a16:creationId xmlns:a16="http://schemas.microsoft.com/office/drawing/2014/main" id="{CFF47E18-A7BC-933A-32DA-B15DD88B59B5}"/>
-              </a:ext>
-            </a:extLst>
-          </p:cNvPr>
-          <p:cNvGrpSpPr/>
+          <p:cNvPr id="14380" name="グループ化 16"/>
+          <p:cNvGrpSpPr>
+            <a:grpSpLocks/>
+          </p:cNvGrpSpPr>
           <p:nvPr/>
         </p:nvGrpSpPr>
-        <p:grpSpPr>
-          <a:xfrm rot="16200000">
-            <a:off x="7148884" y="1031875"/>
-            <a:ext cx="96838" cy="268288"/>
+        <p:grpSpPr bwMode="auto">
+          <a:xfrm rot="-5400000">
+            <a:off x="7148513" y="1031875"/>
+            <a:ext cx="96838" cy="268287"/>
             <a:chOff x="6829997" y="159544"/>
             <a:chExt cx="96838" cy="268288"/>
           </a:xfrm>
         </p:grpSpPr>
         <p:sp>
           <p:nvSpPr>
-            <p:cNvPr id="18" name="Rectangle 40">
-              <a:extLst>
-                <a:ext uri="{FF2B5EF4-FFF2-40B4-BE49-F238E27FC236}">
-                  <a16:creationId xmlns:a16="http://schemas.microsoft.com/office/drawing/2014/main" id="{2151D802-35F1-56C6-426A-95CB1029CAAE}"/>
-                </a:ext>
-              </a:extLst>
-            </p:cNvPr>
+            <p:cNvPr id="14391" name="Rectangle 40"/>
             <p:cNvSpPr>
               <a:spLocks noChangeArrowheads="1"/>
             </p:cNvSpPr>
@@ -7060,7 +6992,7 @@
             <a:lstStyle/>
             <a:p>
               <a:pPr algn="ctr"/>
-              <a:endParaRPr lang="ja-JP" altLang="en-US" sz="800" dirty="0"/>
+              <a:endParaRPr lang="ja-JP" altLang="en-US" sz="800"/>
             </a:p>
           </p:txBody>
         </p:sp>
@@ -7068,9 +7000,7 @@
           <p:nvSpPr>
             <p:cNvPr id="19" name="二等辺三角形 18">
               <a:extLst>
-                <a:ext uri="{FF2B5EF4-FFF2-40B4-BE49-F238E27FC236}">
-                  <a16:creationId xmlns:a16="http://schemas.microsoft.com/office/drawing/2014/main" id="{84712D67-E26A-3925-1538-3ADDD456AD8E}"/>
-                </a:ext>
+                <a:ext uri="{FF2B5EF4-FFF2-40B4-BE49-F238E27FC236}"/>
               </a:extLst>
             </p:cNvPr>
             <p:cNvSpPr/>
@@ -7078,8 +7008,8 @@
           </p:nvSpPr>
           <p:spPr>
             <a:xfrm>
-              <a:off x="6844060" y="226504"/>
-              <a:ext cx="72008" cy="135285"/>
+              <a:off x="6844285" y="226219"/>
+              <a:ext cx="71437" cy="134938"/>
             </a:xfrm>
             <a:prstGeom prst="triangle">
               <a:avLst/>
@@ -7107,11 +7037,13 @@
             </a:fontRef>
           </p:style>
           <p:txBody>
-            <a:bodyPr rtlCol="0" anchor="ctr"/>
+            <a:bodyPr anchor="ctr"/>
             <a:lstStyle/>
             <a:p>
-              <a:pPr algn="ctr"/>
-              <a:endParaRPr kumimoji="1" lang="ja-JP" altLang="en-US" dirty="0"/>
+              <a:pPr algn="ctr">
+                <a:defRPr/>
+              </a:pPr>
+              <a:endParaRPr lang="ja-JP" altLang="en-US" dirty="0"/>
             </a:p>
           </p:txBody>
         </p:sp>
@@ -7119,9 +7051,7 @@
           <p:nvCxnSpPr>
             <p:cNvPr id="20" name="直線コネクタ 19">
               <a:extLst>
-                <a:ext uri="{FF2B5EF4-FFF2-40B4-BE49-F238E27FC236}">
-                  <a16:creationId xmlns:a16="http://schemas.microsoft.com/office/drawing/2014/main" id="{2DA90C88-AD42-4B34-9F0C-073812035A29}"/>
-                </a:ext>
+                <a:ext uri="{FF2B5EF4-FFF2-40B4-BE49-F238E27FC236}"/>
               </a:extLst>
             </p:cNvPr>
             <p:cNvCxnSpPr>
@@ -7131,8 +7061,8 @@
           </p:nvCxnSpPr>
           <p:spPr>
             <a:xfrm>
-              <a:off x="6879035" y="183356"/>
-              <a:ext cx="0" cy="218741"/>
+              <a:off x="6877622" y="183356"/>
+              <a:ext cx="0" cy="219076"/>
             </a:xfrm>
             <a:prstGeom prst="line">
               <a:avLst/>
@@ -7162,9 +7092,7 @@
           <p:nvCxnSpPr>
             <p:cNvPr id="21" name="直線コネクタ 20">
               <a:extLst>
-                <a:ext uri="{FF2B5EF4-FFF2-40B4-BE49-F238E27FC236}">
-                  <a16:creationId xmlns:a16="http://schemas.microsoft.com/office/drawing/2014/main" id="{D5DC3818-4E48-0983-044F-F643C0100ED4}"/>
-                </a:ext>
+                <a:ext uri="{FF2B5EF4-FFF2-40B4-BE49-F238E27FC236}"/>
               </a:extLst>
             </p:cNvPr>
             <p:cNvCxnSpPr/>
@@ -7172,8 +7100,8 @@
           </p:nvCxnSpPr>
           <p:spPr>
             <a:xfrm>
-              <a:off x="6841679" y="226504"/>
-              <a:ext cx="72008" cy="0"/>
+              <a:off x="6839521" y="226218"/>
+              <a:ext cx="73025" cy="0"/>
             </a:xfrm>
             <a:prstGeom prst="line">
               <a:avLst/>
@@ -7202,33 +7130,23 @@
       </p:grpSp>
       <p:grpSp>
         <p:nvGrpSpPr>
-          <p:cNvPr id="22" name="グループ化 21">
-            <a:extLst>
-              <a:ext uri="{FF2B5EF4-FFF2-40B4-BE49-F238E27FC236}">
-                <a16:creationId xmlns:a16="http://schemas.microsoft.com/office/drawing/2014/main" id="{1E5FFB26-3E80-5621-01C7-8C34C59B71F2}"/>
-              </a:ext>
-            </a:extLst>
-          </p:cNvPr>
-          <p:cNvGrpSpPr/>
+          <p:cNvPr id="14381" name="グループ化 21"/>
+          <p:cNvGrpSpPr>
+            <a:grpSpLocks/>
+          </p:cNvGrpSpPr>
           <p:nvPr/>
         </p:nvGrpSpPr>
-        <p:grpSpPr>
-          <a:xfrm rot="16200000">
-            <a:off x="7460456" y="1138523"/>
-            <a:ext cx="96838" cy="268288"/>
+        <p:grpSpPr bwMode="auto">
+          <a:xfrm rot="-5400000">
+            <a:off x="7460457" y="1137444"/>
+            <a:ext cx="96837" cy="269875"/>
             <a:chOff x="6829997" y="159544"/>
             <a:chExt cx="96838" cy="268288"/>
           </a:xfrm>
         </p:grpSpPr>
         <p:sp>
           <p:nvSpPr>
-            <p:cNvPr id="23" name="Rectangle 40">
-              <a:extLst>
-                <a:ext uri="{FF2B5EF4-FFF2-40B4-BE49-F238E27FC236}">
-                  <a16:creationId xmlns:a16="http://schemas.microsoft.com/office/drawing/2014/main" id="{3A861B57-5670-3360-93E1-CE4B3D3146A7}"/>
-                </a:ext>
-              </a:extLst>
-            </p:cNvPr>
+            <p:cNvPr id="14387" name="Rectangle 40"/>
             <p:cNvSpPr>
               <a:spLocks noChangeArrowheads="1"/>
             </p:cNvSpPr>
@@ -7259,7 +7177,7 @@
             <a:lstStyle/>
             <a:p>
               <a:pPr algn="ctr"/>
-              <a:endParaRPr lang="ja-JP" altLang="en-US" sz="800" dirty="0"/>
+              <a:endParaRPr lang="ja-JP" altLang="en-US" sz="800"/>
             </a:p>
           </p:txBody>
         </p:sp>
@@ -7267,9 +7185,7 @@
           <p:nvSpPr>
             <p:cNvPr id="24" name="二等辺三角形 23">
               <a:extLst>
-                <a:ext uri="{FF2B5EF4-FFF2-40B4-BE49-F238E27FC236}">
-                  <a16:creationId xmlns:a16="http://schemas.microsoft.com/office/drawing/2014/main" id="{D4E291D7-16B0-731C-FDBD-86A79BF60D91}"/>
-                </a:ext>
+                <a:ext uri="{FF2B5EF4-FFF2-40B4-BE49-F238E27FC236}"/>
               </a:extLst>
             </p:cNvPr>
             <p:cNvSpPr/>
@@ -7277,8 +7193,8 @@
           </p:nvSpPr>
           <p:spPr>
             <a:xfrm>
-              <a:off x="6844060" y="226504"/>
-              <a:ext cx="72008" cy="135285"/>
+              <a:off x="6844285" y="225827"/>
+              <a:ext cx="71439" cy="135722"/>
             </a:xfrm>
             <a:prstGeom prst="triangle">
               <a:avLst/>
@@ -7306,11 +7222,13 @@
             </a:fontRef>
           </p:style>
           <p:txBody>
-            <a:bodyPr rtlCol="0" anchor="ctr"/>
+            <a:bodyPr anchor="ctr"/>
             <a:lstStyle/>
             <a:p>
-              <a:pPr algn="ctr"/>
-              <a:endParaRPr kumimoji="1" lang="ja-JP" altLang="en-US" dirty="0"/>
+              <a:pPr algn="ctr">
+                <a:defRPr/>
+              </a:pPr>
+              <a:endParaRPr lang="ja-JP" altLang="en-US" dirty="0"/>
             </a:p>
           </p:txBody>
         </p:sp>
@@ -7318,9 +7236,7 @@
           <p:nvCxnSpPr>
             <p:cNvPr id="25" name="直線コネクタ 24">
               <a:extLst>
-                <a:ext uri="{FF2B5EF4-FFF2-40B4-BE49-F238E27FC236}">
-                  <a16:creationId xmlns:a16="http://schemas.microsoft.com/office/drawing/2014/main" id="{491F6C28-EB19-DD85-2EF0-0131902F50C9}"/>
-                </a:ext>
+                <a:ext uri="{FF2B5EF4-FFF2-40B4-BE49-F238E27FC236}"/>
               </a:extLst>
             </p:cNvPr>
             <p:cNvCxnSpPr>
@@ -7330,8 +7246,8 @@
           </p:nvCxnSpPr>
           <p:spPr>
             <a:xfrm>
-              <a:off x="6879035" y="183356"/>
-              <a:ext cx="0" cy="218741"/>
+              <a:off x="6877623" y="183216"/>
+              <a:ext cx="0" cy="219365"/>
             </a:xfrm>
             <a:prstGeom prst="line">
               <a:avLst/>
@@ -7361,9 +7277,7 @@
           <p:nvCxnSpPr>
             <p:cNvPr id="26" name="直線コネクタ 25">
               <a:extLst>
-                <a:ext uri="{FF2B5EF4-FFF2-40B4-BE49-F238E27FC236}">
-                  <a16:creationId xmlns:a16="http://schemas.microsoft.com/office/drawing/2014/main" id="{BB47D7FD-69AA-4E12-1C3C-B8BF1FE0F49D}"/>
-                </a:ext>
+                <a:ext uri="{FF2B5EF4-FFF2-40B4-BE49-F238E27FC236}"/>
               </a:extLst>
             </p:cNvPr>
             <p:cNvCxnSpPr/>
@@ -7371,8 +7285,8 @@
           </p:nvCxnSpPr>
           <p:spPr>
             <a:xfrm>
-              <a:off x="6841679" y="226504"/>
-              <a:ext cx="72008" cy="0"/>
+              <a:off x="6839522" y="225826"/>
+              <a:ext cx="73026" cy="0"/>
             </a:xfrm>
             <a:prstGeom prst="line">
               <a:avLst/>
@@ -7401,33 +7315,23 @@
       </p:grpSp>
       <p:grpSp>
         <p:nvGrpSpPr>
-          <p:cNvPr id="27" name="グループ化 26">
-            <a:extLst>
-              <a:ext uri="{FF2B5EF4-FFF2-40B4-BE49-F238E27FC236}">
-                <a16:creationId xmlns:a16="http://schemas.microsoft.com/office/drawing/2014/main" id="{0EB0E093-6883-A1A3-71E9-E2525BB452E1}"/>
-              </a:ext>
-            </a:extLst>
-          </p:cNvPr>
-          <p:cNvGrpSpPr/>
+          <p:cNvPr id="14382" name="グループ化 26"/>
+          <p:cNvGrpSpPr>
+            <a:grpSpLocks/>
+          </p:cNvGrpSpPr>
           <p:nvPr/>
         </p:nvGrpSpPr>
-        <p:grpSpPr>
-          <a:xfrm rot="16200000">
-            <a:off x="6514306" y="3303587"/>
-            <a:ext cx="96838" cy="268288"/>
+        <p:grpSpPr bwMode="auto">
+          <a:xfrm rot="-5400000">
+            <a:off x="6514307" y="3302794"/>
+            <a:ext cx="96837" cy="269875"/>
             <a:chOff x="6829997" y="159544"/>
             <a:chExt cx="96838" cy="268288"/>
           </a:xfrm>
         </p:grpSpPr>
         <p:sp>
           <p:nvSpPr>
-            <p:cNvPr id="28" name="Rectangle 40">
-              <a:extLst>
-                <a:ext uri="{FF2B5EF4-FFF2-40B4-BE49-F238E27FC236}">
-                  <a16:creationId xmlns:a16="http://schemas.microsoft.com/office/drawing/2014/main" id="{3E872EA4-95BE-93E1-7418-B7E05B79FED7}"/>
-                </a:ext>
-              </a:extLst>
-            </p:cNvPr>
+            <p:cNvPr id="14383" name="Rectangle 40"/>
             <p:cNvSpPr>
               <a:spLocks noChangeArrowheads="1"/>
             </p:cNvSpPr>
@@ -7458,7 +7362,7 @@
             <a:lstStyle/>
             <a:p>
               <a:pPr algn="ctr"/>
-              <a:endParaRPr lang="ja-JP" altLang="en-US" sz="800" dirty="0"/>
+              <a:endParaRPr lang="ja-JP" altLang="en-US" sz="800"/>
             </a:p>
           </p:txBody>
         </p:sp>
@@ -7466,9 +7370,7 @@
           <p:nvSpPr>
             <p:cNvPr id="29" name="二等辺三角形 28">
               <a:extLst>
-                <a:ext uri="{FF2B5EF4-FFF2-40B4-BE49-F238E27FC236}">
-                  <a16:creationId xmlns:a16="http://schemas.microsoft.com/office/drawing/2014/main" id="{DC93944B-C200-ACAA-0A44-958CE12ED29C}"/>
-                </a:ext>
+                <a:ext uri="{FF2B5EF4-FFF2-40B4-BE49-F238E27FC236}"/>
               </a:extLst>
             </p:cNvPr>
             <p:cNvSpPr/>
@@ -7476,8 +7378,8 @@
           </p:nvSpPr>
           <p:spPr>
             <a:xfrm>
-              <a:off x="6844060" y="226504"/>
-              <a:ext cx="72008" cy="135285"/>
+              <a:off x="6844285" y="225827"/>
+              <a:ext cx="71439" cy="135722"/>
             </a:xfrm>
             <a:prstGeom prst="triangle">
               <a:avLst/>
@@ -7505,11 +7407,13 @@
             </a:fontRef>
           </p:style>
           <p:txBody>
-            <a:bodyPr rtlCol="0" anchor="ctr"/>
+            <a:bodyPr anchor="ctr"/>
             <a:lstStyle/>
             <a:p>
-              <a:pPr algn="ctr"/>
-              <a:endParaRPr kumimoji="1" lang="ja-JP" altLang="en-US" dirty="0"/>
+              <a:pPr algn="ctr">
+                <a:defRPr/>
+              </a:pPr>
+              <a:endParaRPr lang="ja-JP" altLang="en-US" dirty="0"/>
             </a:p>
           </p:txBody>
         </p:sp>
@@ -7517,9 +7421,7 @@
           <p:nvCxnSpPr>
             <p:cNvPr id="30" name="直線コネクタ 29">
               <a:extLst>
-                <a:ext uri="{FF2B5EF4-FFF2-40B4-BE49-F238E27FC236}">
-                  <a16:creationId xmlns:a16="http://schemas.microsoft.com/office/drawing/2014/main" id="{C3B575B9-9CC7-C18B-39EA-B7034A89DDC3}"/>
-                </a:ext>
+                <a:ext uri="{FF2B5EF4-FFF2-40B4-BE49-F238E27FC236}"/>
               </a:extLst>
             </p:cNvPr>
             <p:cNvCxnSpPr>
@@ -7529,8 +7431,8 @@
           </p:nvCxnSpPr>
           <p:spPr>
             <a:xfrm>
-              <a:off x="6879035" y="183356"/>
-              <a:ext cx="0" cy="218741"/>
+              <a:off x="6877623" y="183216"/>
+              <a:ext cx="0" cy="219365"/>
             </a:xfrm>
             <a:prstGeom prst="line">
               <a:avLst/>
@@ -7560,9 +7462,7 @@
           <p:nvCxnSpPr>
             <p:cNvPr id="31" name="直線コネクタ 30">
               <a:extLst>
-                <a:ext uri="{FF2B5EF4-FFF2-40B4-BE49-F238E27FC236}">
-                  <a16:creationId xmlns:a16="http://schemas.microsoft.com/office/drawing/2014/main" id="{BA288C8A-5531-9939-573B-D0005CB60D92}"/>
-                </a:ext>
+                <a:ext uri="{FF2B5EF4-FFF2-40B4-BE49-F238E27FC236}"/>
               </a:extLst>
             </p:cNvPr>
             <p:cNvCxnSpPr/>
@@ -7570,8 +7470,8 @@
           </p:nvCxnSpPr>
           <p:spPr>
             <a:xfrm>
-              <a:off x="6841679" y="226504"/>
-              <a:ext cx="72008" cy="0"/>
+              <a:off x="6839522" y="225826"/>
+              <a:ext cx="73026" cy="0"/>
             </a:xfrm>
             <a:prstGeom prst="line">
               <a:avLst/>

</xml_diff>